<commit_message>
way too much stuff changed
</commit_message>
<xml_diff>
--- a/results/figures/ibutton.simulation/modif.boxplot.pptx
+++ b/results/figures/ibutton.simulation/modif.boxplot.pptx
@@ -5,7 +5,8 @@
     <p:sldMasterId id="2147483648" r:id="rId1"/>
   </p:sldMasterIdLst>
   <p:sldIdLst>
-    <p:sldId id="256" r:id="rId2"/>
+    <p:sldId id="257" r:id="rId2"/>
+    <p:sldId id="256" r:id="rId3"/>
   </p:sldIdLst>
   <p:sldSz cx="12192000" cy="6858000"/>
   <p:notesSz cx="6858000" cy="9144000"/>
@@ -154,10 +155,9 @@
           </a:lstStyle>
           <a:p>
             <a:r>
-              <a:rPr lang="en-US" smtClean="0"/>
+              <a:rPr lang="en-US"/>
               <a:t>Click to edit Master title style</a:t>
             </a:r>
-            <a:endParaRPr lang="en-US"/>
           </a:p>
         </p:txBody>
       </p:sp>
@@ -219,10 +219,9 @@
           </a:lstStyle>
           <a:p>
             <a:r>
-              <a:rPr lang="en-US" smtClean="0"/>
+              <a:rPr lang="en-US"/>
               <a:t>Click to edit Master subtitle style</a:t>
             </a:r>
-            <a:endParaRPr lang="en-US"/>
           </a:p>
         </p:txBody>
       </p:sp>
@@ -243,7 +242,7 @@
           <a:p>
             <a:fld id="{D2700B4B-2263-40ED-9609-E07096205E49}" type="datetimeFigureOut">
               <a:rPr lang="en-US" smtClean="0"/>
-              <a:t>1/29/2024</a:t>
+              <a:t>10/29/2025</a:t>
             </a:fld>
             <a:endParaRPr lang="en-US"/>
           </a:p>
@@ -337,10 +336,9 @@
           <a:lstStyle/>
           <a:p>
             <a:r>
-              <a:rPr lang="en-US" smtClean="0"/>
+              <a:rPr lang="en-US"/>
               <a:t>Click to edit Master title style</a:t>
             </a:r>
-            <a:endParaRPr lang="en-US"/>
           </a:p>
         </p:txBody>
       </p:sp>
@@ -361,38 +359,37 @@
           <a:p>
             <a:pPr lvl="0"/>
             <a:r>
-              <a:rPr lang="en-US" smtClean="0"/>
+              <a:rPr lang="en-US"/>
               <a:t>Edit Master text styles</a:t>
             </a:r>
           </a:p>
           <a:p>
             <a:pPr lvl="1"/>
             <a:r>
-              <a:rPr lang="en-US" smtClean="0"/>
+              <a:rPr lang="en-US"/>
               <a:t>Second level</a:t>
             </a:r>
           </a:p>
           <a:p>
             <a:pPr lvl="2"/>
             <a:r>
-              <a:rPr lang="en-US" smtClean="0"/>
+              <a:rPr lang="en-US"/>
               <a:t>Third level</a:t>
             </a:r>
           </a:p>
           <a:p>
             <a:pPr lvl="3"/>
             <a:r>
-              <a:rPr lang="en-US" smtClean="0"/>
+              <a:rPr lang="en-US"/>
               <a:t>Fourth level</a:t>
             </a:r>
           </a:p>
           <a:p>
             <a:pPr lvl="4"/>
             <a:r>
-              <a:rPr lang="en-US" smtClean="0"/>
+              <a:rPr lang="en-US"/>
               <a:t>Fifth level</a:t>
             </a:r>
-            <a:endParaRPr lang="en-US"/>
           </a:p>
         </p:txBody>
       </p:sp>
@@ -413,7 +410,7 @@
           <a:p>
             <a:fld id="{D2700B4B-2263-40ED-9609-E07096205E49}" type="datetimeFigureOut">
               <a:rPr lang="en-US" smtClean="0"/>
-              <a:t>1/29/2024</a:t>
+              <a:t>10/29/2025</a:t>
             </a:fld>
             <a:endParaRPr lang="en-US"/>
           </a:p>
@@ -512,10 +509,9 @@
           <a:lstStyle/>
           <a:p>
             <a:r>
-              <a:rPr lang="en-US" smtClean="0"/>
+              <a:rPr lang="en-US"/>
               <a:t>Click to edit Master title style</a:t>
             </a:r>
-            <a:endParaRPr lang="en-US"/>
           </a:p>
         </p:txBody>
       </p:sp>
@@ -541,38 +537,37 @@
           <a:p>
             <a:pPr lvl="0"/>
             <a:r>
-              <a:rPr lang="en-US" smtClean="0"/>
+              <a:rPr lang="en-US"/>
               <a:t>Edit Master text styles</a:t>
             </a:r>
           </a:p>
           <a:p>
             <a:pPr lvl="1"/>
             <a:r>
-              <a:rPr lang="en-US" smtClean="0"/>
+              <a:rPr lang="en-US"/>
               <a:t>Second level</a:t>
             </a:r>
           </a:p>
           <a:p>
             <a:pPr lvl="2"/>
             <a:r>
-              <a:rPr lang="en-US" smtClean="0"/>
+              <a:rPr lang="en-US"/>
               <a:t>Third level</a:t>
             </a:r>
           </a:p>
           <a:p>
             <a:pPr lvl="3"/>
             <a:r>
-              <a:rPr lang="en-US" smtClean="0"/>
+              <a:rPr lang="en-US"/>
               <a:t>Fourth level</a:t>
             </a:r>
           </a:p>
           <a:p>
             <a:pPr lvl="4"/>
             <a:r>
-              <a:rPr lang="en-US" smtClean="0"/>
+              <a:rPr lang="en-US"/>
               <a:t>Fifth level</a:t>
             </a:r>
-            <a:endParaRPr lang="en-US"/>
           </a:p>
         </p:txBody>
       </p:sp>
@@ -593,7 +588,7 @@
           <a:p>
             <a:fld id="{D2700B4B-2263-40ED-9609-E07096205E49}" type="datetimeFigureOut">
               <a:rPr lang="en-US" smtClean="0"/>
-              <a:t>1/29/2024</a:t>
+              <a:t>10/29/2025</a:t>
             </a:fld>
             <a:endParaRPr lang="en-US"/>
           </a:p>
@@ -687,10 +682,9 @@
           <a:lstStyle/>
           <a:p>
             <a:r>
-              <a:rPr lang="en-US" smtClean="0"/>
+              <a:rPr lang="en-US"/>
               <a:t>Click to edit Master title style</a:t>
             </a:r>
-            <a:endParaRPr lang="en-US"/>
           </a:p>
         </p:txBody>
       </p:sp>
@@ -711,38 +705,37 @@
           <a:p>
             <a:pPr lvl="0"/>
             <a:r>
-              <a:rPr lang="en-US" smtClean="0"/>
+              <a:rPr lang="en-US"/>
               <a:t>Edit Master text styles</a:t>
             </a:r>
           </a:p>
           <a:p>
             <a:pPr lvl="1"/>
             <a:r>
-              <a:rPr lang="en-US" smtClean="0"/>
+              <a:rPr lang="en-US"/>
               <a:t>Second level</a:t>
             </a:r>
           </a:p>
           <a:p>
             <a:pPr lvl="2"/>
             <a:r>
-              <a:rPr lang="en-US" smtClean="0"/>
+              <a:rPr lang="en-US"/>
               <a:t>Third level</a:t>
             </a:r>
           </a:p>
           <a:p>
             <a:pPr lvl="3"/>
             <a:r>
-              <a:rPr lang="en-US" smtClean="0"/>
+              <a:rPr lang="en-US"/>
               <a:t>Fourth level</a:t>
             </a:r>
           </a:p>
           <a:p>
             <a:pPr lvl="4"/>
             <a:r>
-              <a:rPr lang="en-US" smtClean="0"/>
+              <a:rPr lang="en-US"/>
               <a:t>Fifth level</a:t>
             </a:r>
-            <a:endParaRPr lang="en-US"/>
           </a:p>
         </p:txBody>
       </p:sp>
@@ -763,7 +756,7 @@
           <a:p>
             <a:fld id="{D2700B4B-2263-40ED-9609-E07096205E49}" type="datetimeFigureOut">
               <a:rPr lang="en-US" smtClean="0"/>
-              <a:t>1/29/2024</a:t>
+              <a:t>10/29/2025</a:t>
             </a:fld>
             <a:endParaRPr lang="en-US"/>
           </a:p>
@@ -866,10 +859,9 @@
           </a:lstStyle>
           <a:p>
             <a:r>
-              <a:rPr lang="en-US" smtClean="0"/>
+              <a:rPr lang="en-US"/>
               <a:t>Click to edit Master title style</a:t>
             </a:r>
-            <a:endParaRPr lang="en-US"/>
           </a:p>
         </p:txBody>
       </p:sp>
@@ -986,7 +978,7 @@
           <a:p>
             <a:pPr lvl="0"/>
             <a:r>
-              <a:rPr lang="en-US" smtClean="0"/>
+              <a:rPr lang="en-US"/>
               <a:t>Edit Master text styles</a:t>
             </a:r>
           </a:p>
@@ -1009,7 +1001,7 @@
           <a:p>
             <a:fld id="{D2700B4B-2263-40ED-9609-E07096205E49}" type="datetimeFigureOut">
               <a:rPr lang="en-US" smtClean="0"/>
-              <a:t>1/29/2024</a:t>
+              <a:t>10/29/2025</a:t>
             </a:fld>
             <a:endParaRPr lang="en-US"/>
           </a:p>
@@ -1103,10 +1095,9 @@
           <a:lstStyle/>
           <a:p>
             <a:r>
-              <a:rPr lang="en-US" smtClean="0"/>
+              <a:rPr lang="en-US"/>
               <a:t>Click to edit Master title style</a:t>
             </a:r>
-            <a:endParaRPr lang="en-US"/>
           </a:p>
         </p:txBody>
       </p:sp>
@@ -1132,38 +1123,37 @@
           <a:p>
             <a:pPr lvl="0"/>
             <a:r>
-              <a:rPr lang="en-US" smtClean="0"/>
+              <a:rPr lang="en-US"/>
               <a:t>Edit Master text styles</a:t>
             </a:r>
           </a:p>
           <a:p>
             <a:pPr lvl="1"/>
             <a:r>
-              <a:rPr lang="en-US" smtClean="0"/>
+              <a:rPr lang="en-US"/>
               <a:t>Second level</a:t>
             </a:r>
           </a:p>
           <a:p>
             <a:pPr lvl="2"/>
             <a:r>
-              <a:rPr lang="en-US" smtClean="0"/>
+              <a:rPr lang="en-US"/>
               <a:t>Third level</a:t>
             </a:r>
           </a:p>
           <a:p>
             <a:pPr lvl="3"/>
             <a:r>
-              <a:rPr lang="en-US" smtClean="0"/>
+              <a:rPr lang="en-US"/>
               <a:t>Fourth level</a:t>
             </a:r>
           </a:p>
           <a:p>
             <a:pPr lvl="4"/>
             <a:r>
-              <a:rPr lang="en-US" smtClean="0"/>
+              <a:rPr lang="en-US"/>
               <a:t>Fifth level</a:t>
             </a:r>
-            <a:endParaRPr lang="en-US"/>
           </a:p>
         </p:txBody>
       </p:sp>
@@ -1189,38 +1179,37 @@
           <a:p>
             <a:pPr lvl="0"/>
             <a:r>
-              <a:rPr lang="en-US" smtClean="0"/>
+              <a:rPr lang="en-US"/>
               <a:t>Edit Master text styles</a:t>
             </a:r>
           </a:p>
           <a:p>
             <a:pPr lvl="1"/>
             <a:r>
-              <a:rPr lang="en-US" smtClean="0"/>
+              <a:rPr lang="en-US"/>
               <a:t>Second level</a:t>
             </a:r>
           </a:p>
           <a:p>
             <a:pPr lvl="2"/>
             <a:r>
-              <a:rPr lang="en-US" smtClean="0"/>
+              <a:rPr lang="en-US"/>
               <a:t>Third level</a:t>
             </a:r>
           </a:p>
           <a:p>
             <a:pPr lvl="3"/>
             <a:r>
-              <a:rPr lang="en-US" smtClean="0"/>
+              <a:rPr lang="en-US"/>
               <a:t>Fourth level</a:t>
             </a:r>
           </a:p>
           <a:p>
             <a:pPr lvl="4"/>
             <a:r>
-              <a:rPr lang="en-US" smtClean="0"/>
+              <a:rPr lang="en-US"/>
               <a:t>Fifth level</a:t>
             </a:r>
-            <a:endParaRPr lang="en-US"/>
           </a:p>
         </p:txBody>
       </p:sp>
@@ -1241,7 +1230,7 @@
           <a:p>
             <a:fld id="{D2700B4B-2263-40ED-9609-E07096205E49}" type="datetimeFigureOut">
               <a:rPr lang="en-US" smtClean="0"/>
-              <a:t>1/29/2024</a:t>
+              <a:t>10/29/2025</a:t>
             </a:fld>
             <a:endParaRPr lang="en-US"/>
           </a:p>
@@ -1340,10 +1329,9 @@
           <a:lstStyle/>
           <a:p>
             <a:r>
-              <a:rPr lang="en-US" smtClean="0"/>
+              <a:rPr lang="en-US"/>
               <a:t>Click to edit Master title style</a:t>
             </a:r>
-            <a:endParaRPr lang="en-US"/>
           </a:p>
         </p:txBody>
       </p:sp>
@@ -1406,7 +1394,7 @@
           <a:p>
             <a:pPr lvl="0"/>
             <a:r>
-              <a:rPr lang="en-US" smtClean="0"/>
+              <a:rPr lang="en-US"/>
               <a:t>Edit Master text styles</a:t>
             </a:r>
           </a:p>
@@ -1434,38 +1422,37 @@
           <a:p>
             <a:pPr lvl="0"/>
             <a:r>
-              <a:rPr lang="en-US" smtClean="0"/>
+              <a:rPr lang="en-US"/>
               <a:t>Edit Master text styles</a:t>
             </a:r>
           </a:p>
           <a:p>
             <a:pPr lvl="1"/>
             <a:r>
-              <a:rPr lang="en-US" smtClean="0"/>
+              <a:rPr lang="en-US"/>
               <a:t>Second level</a:t>
             </a:r>
           </a:p>
           <a:p>
             <a:pPr lvl="2"/>
             <a:r>
-              <a:rPr lang="en-US" smtClean="0"/>
+              <a:rPr lang="en-US"/>
               <a:t>Third level</a:t>
             </a:r>
           </a:p>
           <a:p>
             <a:pPr lvl="3"/>
             <a:r>
-              <a:rPr lang="en-US" smtClean="0"/>
+              <a:rPr lang="en-US"/>
               <a:t>Fourth level</a:t>
             </a:r>
           </a:p>
           <a:p>
             <a:pPr lvl="4"/>
             <a:r>
-              <a:rPr lang="en-US" smtClean="0"/>
+              <a:rPr lang="en-US"/>
               <a:t>Fifth level</a:t>
             </a:r>
-            <a:endParaRPr lang="en-US"/>
           </a:p>
         </p:txBody>
       </p:sp>
@@ -1528,7 +1515,7 @@
           <a:p>
             <a:pPr lvl="0"/>
             <a:r>
-              <a:rPr lang="en-US" smtClean="0"/>
+              <a:rPr lang="en-US"/>
               <a:t>Edit Master text styles</a:t>
             </a:r>
           </a:p>
@@ -1556,38 +1543,37 @@
           <a:p>
             <a:pPr lvl="0"/>
             <a:r>
-              <a:rPr lang="en-US" smtClean="0"/>
+              <a:rPr lang="en-US"/>
               <a:t>Edit Master text styles</a:t>
             </a:r>
           </a:p>
           <a:p>
             <a:pPr lvl="1"/>
             <a:r>
-              <a:rPr lang="en-US" smtClean="0"/>
+              <a:rPr lang="en-US"/>
               <a:t>Second level</a:t>
             </a:r>
           </a:p>
           <a:p>
             <a:pPr lvl="2"/>
             <a:r>
-              <a:rPr lang="en-US" smtClean="0"/>
+              <a:rPr lang="en-US"/>
               <a:t>Third level</a:t>
             </a:r>
           </a:p>
           <a:p>
             <a:pPr lvl="3"/>
             <a:r>
-              <a:rPr lang="en-US" smtClean="0"/>
+              <a:rPr lang="en-US"/>
               <a:t>Fourth level</a:t>
             </a:r>
           </a:p>
           <a:p>
             <a:pPr lvl="4"/>
             <a:r>
-              <a:rPr lang="en-US" smtClean="0"/>
+              <a:rPr lang="en-US"/>
               <a:t>Fifth level</a:t>
             </a:r>
-            <a:endParaRPr lang="en-US"/>
           </a:p>
         </p:txBody>
       </p:sp>
@@ -1608,7 +1594,7 @@
           <a:p>
             <a:fld id="{D2700B4B-2263-40ED-9609-E07096205E49}" type="datetimeFigureOut">
               <a:rPr lang="en-US" smtClean="0"/>
-              <a:t>1/29/2024</a:t>
+              <a:t>10/29/2025</a:t>
             </a:fld>
             <a:endParaRPr lang="en-US"/>
           </a:p>
@@ -1702,10 +1688,9 @@
           <a:lstStyle/>
           <a:p>
             <a:r>
-              <a:rPr lang="en-US" smtClean="0"/>
+              <a:rPr lang="en-US"/>
               <a:t>Click to edit Master title style</a:t>
             </a:r>
-            <a:endParaRPr lang="en-US"/>
           </a:p>
         </p:txBody>
       </p:sp>
@@ -1726,7 +1711,7 @@
           <a:p>
             <a:fld id="{D2700B4B-2263-40ED-9609-E07096205E49}" type="datetimeFigureOut">
               <a:rPr lang="en-US" smtClean="0"/>
-              <a:t>1/29/2024</a:t>
+              <a:t>10/29/2025</a:t>
             </a:fld>
             <a:endParaRPr lang="en-US"/>
           </a:p>
@@ -1821,7 +1806,7 @@
           <a:p>
             <a:fld id="{D2700B4B-2263-40ED-9609-E07096205E49}" type="datetimeFigureOut">
               <a:rPr lang="en-US" smtClean="0"/>
-              <a:t>1/29/2024</a:t>
+              <a:t>10/29/2025</a:t>
             </a:fld>
             <a:endParaRPr lang="en-US"/>
           </a:p>
@@ -1924,10 +1909,9 @@
           </a:lstStyle>
           <a:p>
             <a:r>
-              <a:rPr lang="en-US" smtClean="0"/>
+              <a:rPr lang="en-US"/>
               <a:t>Click to edit Master title style</a:t>
             </a:r>
-            <a:endParaRPr lang="en-US"/>
           </a:p>
         </p:txBody>
       </p:sp>
@@ -1981,38 +1965,37 @@
           <a:p>
             <a:pPr lvl="0"/>
             <a:r>
-              <a:rPr lang="en-US" smtClean="0"/>
+              <a:rPr lang="en-US"/>
               <a:t>Edit Master text styles</a:t>
             </a:r>
           </a:p>
           <a:p>
             <a:pPr lvl="1"/>
             <a:r>
-              <a:rPr lang="en-US" smtClean="0"/>
+              <a:rPr lang="en-US"/>
               <a:t>Second level</a:t>
             </a:r>
           </a:p>
           <a:p>
             <a:pPr lvl="2"/>
             <a:r>
-              <a:rPr lang="en-US" smtClean="0"/>
+              <a:rPr lang="en-US"/>
               <a:t>Third level</a:t>
             </a:r>
           </a:p>
           <a:p>
             <a:pPr lvl="3"/>
             <a:r>
-              <a:rPr lang="en-US" smtClean="0"/>
+              <a:rPr lang="en-US"/>
               <a:t>Fourth level</a:t>
             </a:r>
           </a:p>
           <a:p>
             <a:pPr lvl="4"/>
             <a:r>
-              <a:rPr lang="en-US" smtClean="0"/>
+              <a:rPr lang="en-US"/>
               <a:t>Fifth level</a:t>
             </a:r>
-            <a:endParaRPr lang="en-US"/>
           </a:p>
         </p:txBody>
       </p:sp>
@@ -2075,7 +2058,7 @@
           <a:p>
             <a:pPr lvl="0"/>
             <a:r>
-              <a:rPr lang="en-US" smtClean="0"/>
+              <a:rPr lang="en-US"/>
               <a:t>Edit Master text styles</a:t>
             </a:r>
           </a:p>
@@ -2098,7 +2081,7 @@
           <a:p>
             <a:fld id="{D2700B4B-2263-40ED-9609-E07096205E49}" type="datetimeFigureOut">
               <a:rPr lang="en-US" smtClean="0"/>
-              <a:t>1/29/2024</a:t>
+              <a:t>10/29/2025</a:t>
             </a:fld>
             <a:endParaRPr lang="en-US"/>
           </a:p>
@@ -2201,10 +2184,9 @@
           </a:lstStyle>
           <a:p>
             <a:r>
-              <a:rPr lang="en-US" smtClean="0"/>
+              <a:rPr lang="en-US"/>
               <a:t>Click to edit Master title style</a:t>
             </a:r>
-            <a:endParaRPr lang="en-US"/>
           </a:p>
         </p:txBody>
       </p:sp>
@@ -2328,7 +2310,7 @@
           <a:p>
             <a:pPr lvl="0"/>
             <a:r>
-              <a:rPr lang="en-US" smtClean="0"/>
+              <a:rPr lang="en-US"/>
               <a:t>Edit Master text styles</a:t>
             </a:r>
           </a:p>
@@ -2351,7 +2333,7 @@
           <a:p>
             <a:fld id="{D2700B4B-2263-40ED-9609-E07096205E49}" type="datetimeFigureOut">
               <a:rPr lang="en-US" smtClean="0"/>
-              <a:t>1/29/2024</a:t>
+              <a:t>10/29/2025</a:t>
             </a:fld>
             <a:endParaRPr lang="en-US"/>
           </a:p>
@@ -2460,10 +2442,9 @@
           <a:lstStyle/>
           <a:p>
             <a:r>
-              <a:rPr lang="en-US" smtClean="0"/>
+              <a:rPr lang="en-US"/>
               <a:t>Click to edit Master title style</a:t>
             </a:r>
-            <a:endParaRPr lang="en-US"/>
           </a:p>
         </p:txBody>
       </p:sp>
@@ -2494,38 +2475,37 @@
           <a:p>
             <a:pPr lvl="0"/>
             <a:r>
-              <a:rPr lang="en-US" smtClean="0"/>
+              <a:rPr lang="en-US"/>
               <a:t>Edit Master text styles</a:t>
             </a:r>
           </a:p>
           <a:p>
             <a:pPr lvl="1"/>
             <a:r>
-              <a:rPr lang="en-US" smtClean="0"/>
+              <a:rPr lang="en-US"/>
               <a:t>Second level</a:t>
             </a:r>
           </a:p>
           <a:p>
             <a:pPr lvl="2"/>
             <a:r>
-              <a:rPr lang="en-US" smtClean="0"/>
+              <a:rPr lang="en-US"/>
               <a:t>Third level</a:t>
             </a:r>
           </a:p>
           <a:p>
             <a:pPr lvl="3"/>
             <a:r>
-              <a:rPr lang="en-US" smtClean="0"/>
+              <a:rPr lang="en-US"/>
               <a:t>Fourth level</a:t>
             </a:r>
           </a:p>
           <a:p>
             <a:pPr lvl="4"/>
             <a:r>
-              <a:rPr lang="en-US" smtClean="0"/>
+              <a:rPr lang="en-US"/>
               <a:t>Fifth level</a:t>
             </a:r>
-            <a:endParaRPr lang="en-US"/>
           </a:p>
         </p:txBody>
       </p:sp>
@@ -2564,7 +2544,7 @@
           <a:p>
             <a:fld id="{D2700B4B-2263-40ED-9609-E07096205E49}" type="datetimeFigureOut">
               <a:rPr lang="en-US" smtClean="0"/>
-              <a:t>1/29/2024</a:t>
+              <a:t>10/29/2025</a:t>
             </a:fld>
             <a:endParaRPr lang="en-US"/>
           </a:p>
@@ -2969,6 +2949,332 @@
           <a:chExt cx="0" cy="0"/>
         </a:xfrm>
       </p:grpSpPr>
+      <p:pic>
+        <p:nvPicPr>
+          <p:cNvPr id="3" name="Picture 2" descr="A screenshot of a graph&#10;&#10;AI-generated content may be incorrect.">
+            <a:extLst>
+              <a:ext uri="{FF2B5EF4-FFF2-40B4-BE49-F238E27FC236}">
+                <a16:creationId xmlns:a16="http://schemas.microsoft.com/office/drawing/2014/main" id="{F59EE591-2BBB-311F-56EE-046AF0C31879}"/>
+              </a:ext>
+            </a:extLst>
+          </p:cNvPr>
+          <p:cNvPicPr>
+            <a:picLocks noChangeAspect="1"/>
+          </p:cNvPicPr>
+          <p:nvPr/>
+        </p:nvPicPr>
+        <p:blipFill>
+          <a:blip r:embed="rId2" cstate="print">
+            <a:extLst>
+              <a:ext uri="{28A0092B-C50C-407E-A947-70E740481C1C}">
+                <a14:useLocalDpi xmlns:a14="http://schemas.microsoft.com/office/drawing/2010/main" val="0"/>
+              </a:ext>
+            </a:extLst>
+          </a:blip>
+          <a:stretch>
+            <a:fillRect/>
+          </a:stretch>
+        </p:blipFill>
+        <p:spPr>
+          <a:xfrm>
+            <a:off x="0" y="0"/>
+            <a:ext cx="6477013" cy="3599695"/>
+          </a:xfrm>
+          <a:prstGeom prst="rect">
+            <a:avLst/>
+          </a:prstGeom>
+        </p:spPr>
+      </p:pic>
+      <p:pic>
+        <p:nvPicPr>
+          <p:cNvPr id="5" name="Picture 4" descr="A screenshot of a graph&#10;&#10;AI-generated content may be incorrect.">
+            <a:extLst>
+              <a:ext uri="{FF2B5EF4-FFF2-40B4-BE49-F238E27FC236}">
+                <a16:creationId xmlns:a16="http://schemas.microsoft.com/office/drawing/2014/main" id="{772D26D1-92D8-B1E2-EAF1-F435788DC04D}"/>
+              </a:ext>
+            </a:extLst>
+          </p:cNvPr>
+          <p:cNvPicPr>
+            <a:picLocks noChangeAspect="1"/>
+          </p:cNvPicPr>
+          <p:nvPr/>
+        </p:nvPicPr>
+        <p:blipFill>
+          <a:blip r:embed="rId3" cstate="print">
+            <a:extLst>
+              <a:ext uri="{28A0092B-C50C-407E-A947-70E740481C1C}">
+                <a14:useLocalDpi xmlns:a14="http://schemas.microsoft.com/office/drawing/2010/main" val="0"/>
+              </a:ext>
+            </a:extLst>
+          </a:blip>
+          <a:stretch>
+            <a:fillRect/>
+          </a:stretch>
+        </p:blipFill>
+        <p:spPr>
+          <a:xfrm>
+            <a:off x="8962" y="3429000"/>
+            <a:ext cx="6477013" cy="3599695"/>
+          </a:xfrm>
+          <a:prstGeom prst="rect">
+            <a:avLst/>
+          </a:prstGeom>
+        </p:spPr>
+      </p:pic>
+      <p:pic>
+        <p:nvPicPr>
+          <p:cNvPr id="7" name="Picture 6" descr="A graph with numbers and lines&#10;&#10;AI-generated content may be incorrect.">
+            <a:extLst>
+              <a:ext uri="{FF2B5EF4-FFF2-40B4-BE49-F238E27FC236}">
+                <a16:creationId xmlns:a16="http://schemas.microsoft.com/office/drawing/2014/main" id="{73CC548B-D56F-1A2A-C659-EEE422893041}"/>
+              </a:ext>
+            </a:extLst>
+          </p:cNvPr>
+          <p:cNvPicPr>
+            <a:picLocks noChangeAspect="1"/>
+          </p:cNvPicPr>
+          <p:nvPr/>
+        </p:nvPicPr>
+        <p:blipFill>
+          <a:blip r:embed="rId4" cstate="print">
+            <a:extLst>
+              <a:ext uri="{28A0092B-C50C-407E-A947-70E740481C1C}">
+                <a14:useLocalDpi xmlns:a14="http://schemas.microsoft.com/office/drawing/2010/main" val="0"/>
+              </a:ext>
+            </a:extLst>
+          </a:blip>
+          <a:stretch>
+            <a:fillRect/>
+          </a:stretch>
+        </p:blipFill>
+        <p:spPr>
+          <a:xfrm>
+            <a:off x="6477013" y="3428095"/>
+            <a:ext cx="4678690" cy="3236983"/>
+          </a:xfrm>
+          <a:prstGeom prst="rect">
+            <a:avLst/>
+          </a:prstGeom>
+        </p:spPr>
+      </p:pic>
+      <p:pic>
+        <p:nvPicPr>
+          <p:cNvPr id="9" name="Picture 8" descr="A graph of a wave&#10;&#10;AI-generated content may be incorrect.">
+            <a:extLst>
+              <a:ext uri="{FF2B5EF4-FFF2-40B4-BE49-F238E27FC236}">
+                <a16:creationId xmlns:a16="http://schemas.microsoft.com/office/drawing/2014/main" id="{11B1873E-BA0F-9842-0B74-CA6C41D663BB}"/>
+              </a:ext>
+            </a:extLst>
+          </p:cNvPr>
+          <p:cNvPicPr>
+            <a:picLocks noChangeAspect="1"/>
+          </p:cNvPicPr>
+          <p:nvPr/>
+        </p:nvPicPr>
+        <p:blipFill>
+          <a:blip r:embed="rId5" cstate="print">
+            <a:extLst>
+              <a:ext uri="{28A0092B-C50C-407E-A947-70E740481C1C}">
+                <a14:useLocalDpi xmlns:a14="http://schemas.microsoft.com/office/drawing/2010/main" val="0"/>
+              </a:ext>
+            </a:extLst>
+          </a:blip>
+          <a:stretch>
+            <a:fillRect/>
+          </a:stretch>
+        </p:blipFill>
+        <p:spPr>
+          <a:xfrm>
+            <a:off x="6477013" y="0"/>
+            <a:ext cx="4678690" cy="3236983"/>
+          </a:xfrm>
+          <a:prstGeom prst="rect">
+            <a:avLst/>
+          </a:prstGeom>
+        </p:spPr>
+      </p:pic>
+      <p:sp>
+        <p:nvSpPr>
+          <p:cNvPr id="11" name="TextBox 10">
+            <a:extLst>
+              <a:ext uri="{FF2B5EF4-FFF2-40B4-BE49-F238E27FC236}">
+                <a16:creationId xmlns:a16="http://schemas.microsoft.com/office/drawing/2014/main" id="{1DADA819-055B-E486-DC0A-ADDB039F01EC}"/>
+              </a:ext>
+            </a:extLst>
+          </p:cNvPr>
+          <p:cNvSpPr txBox="1"/>
+          <p:nvPr/>
+        </p:nvSpPr>
+        <p:spPr>
+          <a:xfrm>
+            <a:off x="44822" y="-69912"/>
+            <a:ext cx="312906" cy="400110"/>
+          </a:xfrm>
+          <a:prstGeom prst="rect">
+            <a:avLst/>
+          </a:prstGeom>
+          <a:noFill/>
+        </p:spPr>
+        <p:txBody>
+          <a:bodyPr wrap="none" rtlCol="0">
+            <a:spAutoFit/>
+          </a:bodyPr>
+          <a:lstStyle/>
+          <a:p>
+            <a:r>
+              <a:rPr lang="en-US" sz="2000" b="1" dirty="0">
+                <a:latin typeface="Times New Roman" panose="02020603050405020304" pitchFamily="18" charset="0"/>
+                <a:cs typeface="Times New Roman" panose="02020603050405020304" pitchFamily="18" charset="0"/>
+              </a:rPr>
+              <a:t>a</a:t>
+            </a:r>
+          </a:p>
+        </p:txBody>
+      </p:sp>
+      <p:sp>
+        <p:nvSpPr>
+          <p:cNvPr id="12" name="TextBox 11">
+            <a:extLst>
+              <a:ext uri="{FF2B5EF4-FFF2-40B4-BE49-F238E27FC236}">
+                <a16:creationId xmlns:a16="http://schemas.microsoft.com/office/drawing/2014/main" id="{BEDE7D2B-5AA4-B790-01A5-A395CFF1E7ED}"/>
+              </a:ext>
+            </a:extLst>
+          </p:cNvPr>
+          <p:cNvSpPr txBox="1"/>
+          <p:nvPr/>
+        </p:nvSpPr>
+        <p:spPr>
+          <a:xfrm>
+            <a:off x="6529570" y="-79779"/>
+            <a:ext cx="327334" cy="400110"/>
+          </a:xfrm>
+          <a:prstGeom prst="rect">
+            <a:avLst/>
+          </a:prstGeom>
+          <a:noFill/>
+        </p:spPr>
+        <p:txBody>
+          <a:bodyPr wrap="none" rtlCol="0">
+            <a:spAutoFit/>
+          </a:bodyPr>
+          <a:lstStyle/>
+          <a:p>
+            <a:r>
+              <a:rPr lang="en-US" sz="2000" b="1" dirty="0">
+                <a:latin typeface="Times New Roman" panose="02020603050405020304" pitchFamily="18" charset="0"/>
+                <a:cs typeface="Times New Roman" panose="02020603050405020304" pitchFamily="18" charset="0"/>
+              </a:rPr>
+              <a:t>b</a:t>
+            </a:r>
+          </a:p>
+        </p:txBody>
+      </p:sp>
+      <p:sp>
+        <p:nvSpPr>
+          <p:cNvPr id="13" name="TextBox 12">
+            <a:extLst>
+              <a:ext uri="{FF2B5EF4-FFF2-40B4-BE49-F238E27FC236}">
+                <a16:creationId xmlns:a16="http://schemas.microsoft.com/office/drawing/2014/main" id="{B957D35E-0E4A-E61E-A76D-9B0C9B66328E}"/>
+              </a:ext>
+            </a:extLst>
+          </p:cNvPr>
+          <p:cNvSpPr txBox="1"/>
+          <p:nvPr/>
+        </p:nvSpPr>
+        <p:spPr>
+          <a:xfrm>
+            <a:off x="59248" y="3370500"/>
+            <a:ext cx="298480" cy="400110"/>
+          </a:xfrm>
+          <a:prstGeom prst="rect">
+            <a:avLst/>
+          </a:prstGeom>
+          <a:noFill/>
+        </p:spPr>
+        <p:txBody>
+          <a:bodyPr wrap="none" rtlCol="0">
+            <a:spAutoFit/>
+          </a:bodyPr>
+          <a:lstStyle/>
+          <a:p>
+            <a:r>
+              <a:rPr lang="en-US" sz="2000" b="1" dirty="0">
+                <a:latin typeface="Times New Roman" panose="02020603050405020304" pitchFamily="18" charset="0"/>
+                <a:cs typeface="Times New Roman" panose="02020603050405020304" pitchFamily="18" charset="0"/>
+              </a:rPr>
+              <a:t>c</a:t>
+            </a:r>
+          </a:p>
+        </p:txBody>
+      </p:sp>
+      <p:sp>
+        <p:nvSpPr>
+          <p:cNvPr id="14" name="TextBox 13">
+            <a:extLst>
+              <a:ext uri="{FF2B5EF4-FFF2-40B4-BE49-F238E27FC236}">
+                <a16:creationId xmlns:a16="http://schemas.microsoft.com/office/drawing/2014/main" id="{379FD7EE-4DDD-0BB2-AFCC-4BDCD304245B}"/>
+              </a:ext>
+            </a:extLst>
+          </p:cNvPr>
+          <p:cNvSpPr txBox="1"/>
+          <p:nvPr/>
+        </p:nvSpPr>
+        <p:spPr>
+          <a:xfrm>
+            <a:off x="6534305" y="3359956"/>
+            <a:ext cx="327334" cy="400110"/>
+          </a:xfrm>
+          <a:prstGeom prst="rect">
+            <a:avLst/>
+          </a:prstGeom>
+          <a:noFill/>
+        </p:spPr>
+        <p:txBody>
+          <a:bodyPr wrap="none" rtlCol="0">
+            <a:spAutoFit/>
+          </a:bodyPr>
+          <a:lstStyle/>
+          <a:p>
+            <a:r>
+              <a:rPr lang="en-US" sz="2000" b="1" dirty="0">
+                <a:latin typeface="Times New Roman" panose="02020603050405020304" pitchFamily="18" charset="0"/>
+                <a:cs typeface="Times New Roman" panose="02020603050405020304" pitchFamily="18" charset="0"/>
+              </a:rPr>
+              <a:t>d</a:t>
+            </a:r>
+          </a:p>
+        </p:txBody>
+      </p:sp>
+    </p:spTree>
+    <p:extLst>
+      <p:ext uri="{BB962C8B-B14F-4D97-AF65-F5344CB8AC3E}">
+        <p14:creationId xmlns:p14="http://schemas.microsoft.com/office/powerpoint/2010/main" val="1816925813"/>
+      </p:ext>
+    </p:extLst>
+  </p:cSld>
+  <p:clrMapOvr>
+    <a:masterClrMapping/>
+  </p:clrMapOvr>
+</p:sld>
+</file>
+
+<file path=ppt/slides/slide2.xml><?xml version="1.0" encoding="utf-8"?>
+<p:sld xmlns:a="http://schemas.openxmlformats.org/drawingml/2006/main" xmlns:r="http://schemas.openxmlformats.org/officeDocument/2006/relationships" xmlns:p="http://schemas.openxmlformats.org/presentationml/2006/main">
+  <p:cSld>
+    <p:spTree>
+      <p:nvGrpSpPr>
+        <p:cNvPr id="1" name=""/>
+        <p:cNvGrpSpPr/>
+        <p:nvPr/>
+      </p:nvGrpSpPr>
+      <p:grpSpPr>
+        <a:xfrm>
+          <a:off x="0" y="0"/>
+          <a:ext cx="0" cy="0"/>
+          <a:chOff x="0" y="0"/>
+          <a:chExt cx="0" cy="0"/>
+        </a:xfrm>
+      </p:grpSpPr>
       <p:sp>
         <p:nvSpPr>
           <p:cNvPr id="5" name="TextBox 4"/>
@@ -2992,16 +3298,12 @@
           <a:lstStyle/>
           <a:p>
             <a:r>
-              <a:rPr lang="en-US" sz="1500" dirty="0" smtClean="0">
+              <a:rPr lang="en-US" sz="1500" dirty="0">
                 <a:latin typeface="Times New Roman" panose="02020603050405020304" pitchFamily="18" charset="0"/>
                 <a:cs typeface="Times New Roman" panose="02020603050405020304" pitchFamily="18" charset="0"/>
               </a:rPr>
               <a:t>Norwood</a:t>
             </a:r>
-            <a:endParaRPr lang="en-US" sz="1500" dirty="0">
-              <a:latin typeface="Times New Roman" panose="02020603050405020304" pitchFamily="18" charset="0"/>
-              <a:cs typeface="Times New Roman" panose="02020603050405020304" pitchFamily="18" charset="0"/>
-            </a:endParaRPr>
           </a:p>
         </p:txBody>
       </p:sp>
@@ -3028,16 +3330,12 @@
           <a:lstStyle/>
           <a:p>
             <a:r>
-              <a:rPr lang="en-US" sz="1500" dirty="0" smtClean="0">
+              <a:rPr lang="en-US" sz="1500" dirty="0">
                 <a:latin typeface="Times New Roman" panose="02020603050405020304" pitchFamily="18" charset="0"/>
                 <a:cs typeface="Times New Roman" panose="02020603050405020304" pitchFamily="18" charset="0"/>
               </a:rPr>
               <a:t>Blue Ruin</a:t>
             </a:r>
-            <a:endParaRPr lang="en-US" sz="1500" dirty="0">
-              <a:latin typeface="Times New Roman" panose="02020603050405020304" pitchFamily="18" charset="0"/>
-              <a:cs typeface="Times New Roman" panose="02020603050405020304" pitchFamily="18" charset="0"/>
-            </a:endParaRPr>
           </a:p>
         </p:txBody>
       </p:sp>
@@ -3081,13 +3379,6 @@
   <p:clrMapOvr>
     <a:masterClrMapping/>
   </p:clrMapOvr>
-  <p:timing>
-    <p:tnLst>
-      <p:par>
-        <p:cTn id="1" dur="indefinite" restart="never" nodeType="tmRoot"/>
-      </p:par>
-    </p:tnLst>
-  </p:timing>
 </p:sld>
 </file>
 

</xml_diff>